<commit_message>
Aggiorna la presentazione e migliora la gestione del layout nel generatore di diapositive
</commit_message>
<xml_diff>
--- a/presentation/BSP_presentation.pptx
+++ b/presentation/BSP_presentation.pptx
@@ -1221,7 +1221,7 @@
           <a:lstStyle/>
           <a:p>
             <a:r>
-              <a:t>Bring it home: reproducing this method on a real, independently-annotated dataset confirms the paper's central claim — a non-blind, a priori-informed pipeline outperforms blind ICA, especially under the low-SNR conditions typical of real abdominal recordings. Close with the practical motivation (affordable, non-invasive monitoring) and a few concrete next steps.</a:t>
+              <a:t>Bring it home: reproducing this method on a real, independently annotated dataset confirms the paper's central claim — a non-blind, a priori-informed pipeline outperforms blind ICA, especially under the low-SNR conditions typical of real abdominal recordings. Close with the practical motivation (affordable, non-invasive monitoring) and a few concrete next steps.</a:t>
             </a:r>
           </a:p>
         </p:txBody>
@@ -1711,7 +1711,7 @@
           <a:lstStyle/>
           <a:p>
             <a:r>
-              <a:t>QRS localization follows the paper closely: combine channels via PCA to boost SNR, then find peaks by matched filtering. MECG removal also follows the paper's core idea — average and independently rescale the P, QRS and T segments to account for morphology changing over time — but this implementation regularizes the least-squares fit (Ridge/Tikhonov) for stability, an addition not in the original paper. The image shows the large maternal complexes (S4) almost entirely gone after cancellation (S5).</a:t>
+              <a:t>QRS localisation follows the paper closely: combine channels via PCA to boost SNR, then find peaks by matched filtering. MECG removal also follows the paper's core idea — average and independently rescale the P, QRS and T segments to account for morphology changing over time — but this implementation regularises the least-squares fit (Ridge/Tikhonov) for stability, an addition not in the original paper. The image shows the large maternal complexes (S4) almost entirely gone after cancellation (S5).</a:t>
             </a:r>
           </a:p>
         </p:txBody>
@@ -4987,7 +4987,7 @@
         </p:nvSpPr>
         <p:spPr>
           <a:xfrm>
-            <a:off x="960120" y="3246120"/>
+            <a:off x="960120" y="3408679"/>
             <a:ext cx="1463040" cy="50800"/>
           </a:xfrm>
           <a:prstGeom prst="rect">
@@ -5031,7 +5031,7 @@
         </p:nvSpPr>
         <p:spPr>
           <a:xfrm>
-            <a:off x="914400" y="3429000"/>
+            <a:off x="914400" y="3591560"/>
             <a:ext cx="10332720" cy="640080"/>
           </a:xfrm>
           <a:prstGeom prst="rect">
@@ -5040,7 +5040,7 @@
           <a:noFill/>
         </p:spPr>
         <p:txBody>
-          <a:bodyPr wrap="none">
+          <a:bodyPr wrap="square">
             <a:spAutoFit/>
           </a:bodyPr>
           <a:lstStyle/>
@@ -5074,7 +5074,7 @@
           <a:noFill/>
         </p:spPr>
         <p:txBody>
-          <a:bodyPr wrap="none">
+          <a:bodyPr wrap="square">
             <a:spAutoFit/>
           </a:bodyPr>
           <a:lstStyle/>
@@ -5264,7 +5264,7 @@
           </a:bodyPr>
           <a:lstStyle/>
           <a:p>
-            <a:pPr>
+            <a:pPr marL="274320" indent="-274320">
               <a:spcAft>
                 <a:spcPts val="1200"/>
               </a:spcAft>
@@ -5285,11 +5285,11 @@
                 </a:solidFill>
                 <a:latin typeface="Calibri"/>
               </a:rPr>
-              <a:t>Detected fetal QRS peaks (red) vs. `.fqrs` ground-truth annotations (blue), ±50 ms tolerance</a:t>
-            </a:r>
-          </a:p>
-          <a:p>
-            <a:pPr>
+              <a:t>Detected fetal QRS peaks (red) vs. `.fqrs` ground‑truth annotations (blue), ±50 ms tolerance</a:t>
+            </a:r>
+          </a:p>
+          <a:p>
+            <a:pPr marL="274320" indent="-274320">
               <a:spcAft>
                 <a:spcPts val="1200"/>
               </a:spcAft>
@@ -5310,11 +5310,11 @@
                 </a:solidFill>
                 <a:latin typeface="Calibri"/>
               </a:rPr>
-              <a:t>Real 10-second, 4-channel strip</a:t>
-            </a:r>
-          </a:p>
-          <a:p>
-            <a:pPr>
+              <a:t>Real 10‑second, 4‑channel strip</a:t>
+            </a:r>
+          </a:p>
+          <a:p>
+            <a:pPr marL="274320" indent="-274320">
               <a:spcAft>
                 <a:spcPts val="1200"/>
               </a:spcAft>
@@ -5335,7 +5335,7 @@
                 </a:solidFill>
                 <a:latin typeface="Calibri"/>
               </a:rPr>
-              <a:t>Averaged fetal morphology across 124 ground-truth-matched beats</a:t>
+              <a:t>Averaged fetal morphology across 124 ground‑truth‑matched beats</a:t>
             </a:r>
           </a:p>
         </p:txBody>
@@ -5440,7 +5440,7 @@
                 </a:solidFill>
                 <a:latin typeface="Calibri"/>
               </a:rPr>
-              <a:t>Figure 6. Qualitative validation against ground truth</a:t>
+              <a:t>Figure 5. Qualitative validation against ground truth</a:t>
             </a:r>
           </a:p>
         </p:txBody>
@@ -5462,7 +5462,7 @@
           <a:noFill/>
         </p:spPr>
         <p:txBody>
-          <a:bodyPr wrap="none">
+          <a:bodyPr wrap="square">
             <a:spAutoFit/>
           </a:bodyPr>
           <a:lstStyle/>
@@ -5676,7 +5676,7 @@
           </a:bodyPr>
           <a:lstStyle/>
           <a:p>
-            <a:pPr>
+            <a:pPr marL="274320" indent="-274320">
               <a:spcAft>
                 <a:spcPts val="1200"/>
               </a:spcAft>
@@ -5701,7 +5701,7 @@
             </a:r>
           </a:p>
           <a:p>
-            <a:pPr>
+            <a:pPr marL="274320" indent="-274320">
               <a:spcAft>
                 <a:spcPts val="1200"/>
               </a:spcAft>
@@ -5722,11 +5722,11 @@
                 </a:solidFill>
                 <a:latin typeface="Calibri"/>
               </a:rPr>
-              <a:t>Best independent component auto-selected by FHR-detection yield</a:t>
-            </a:r>
-          </a:p>
-          <a:p>
-            <a:pPr>
+              <a:t>Best independent component auto‑selected by FHR‑detection yield</a:t>
+            </a:r>
+          </a:p>
+          <a:p>
+            <a:pPr marL="274320" indent="-274320">
               <a:spcAft>
                 <a:spcPts val="1200"/>
               </a:spcAft>
@@ -5747,7 +5747,7 @@
                 </a:solidFill>
                 <a:latin typeface="Calibri"/>
               </a:rPr>
-              <a:t>Note: the paper used JADE; this implementation uses FastICA (same blind-source-separation family)</a:t>
+              <a:t>Note: the paper used JADE; this implementation uses FastICA (same blind‑source‑separation family)</a:t>
             </a:r>
           </a:p>
         </p:txBody>
@@ -5852,7 +5852,7 @@
                 </a:solidFill>
                 <a:latin typeface="Calibri"/>
               </a:rPr>
-              <a:t>Figure 7. Baseline comparison: the ICA pipeline</a:t>
+              <a:t>Figure 6. Baseline comparison: the ICA pipeline</a:t>
             </a:r>
           </a:p>
         </p:txBody>
@@ -5874,7 +5874,7 @@
           <a:noFill/>
         </p:spPr>
         <p:txBody>
-          <a:bodyPr wrap="none">
+          <a:bodyPr wrap="square">
             <a:spAutoFit/>
           </a:bodyPr>
           <a:lstStyle/>
@@ -6118,7 +6118,7 @@
                 </a:solidFill>
                 <a:latin typeface="Calibri"/>
               </a:rPr>
-              <a:t>Success = ≥60% of the recording covered by physiologically valid, RR-interval-derived FHR estimates</a:t>
+              <a:t>Success = ≥60% of the recording covered by physiologically valid, RR‑interval‑derived FHR estimates</a:t>
             </a:r>
           </a:p>
         </p:txBody>
@@ -6175,7 +6175,7 @@
                 </a:solidFill>
                 <a:latin typeface="Calibri"/>
               </a:rPr>
-              <a:t>Reliability = 1 − (outliers / total), outlier = &gt;10 bpm deviation from the 10s-block median FHR</a:t>
+              <a:t>Reliability = 1 − (outliers / total), outlier = &gt;10 bpm deviation from the 10s‑block median FHR</a:t>
             </a:r>
           </a:p>
         </p:txBody>
@@ -6346,7 +6346,7 @@
                 </a:solidFill>
                 <a:latin typeface="Calibri"/>
               </a:rPr>
-              <a:t>FHR-value MAE / RMSE (bpm) — estimated vs. ground-truth FHR, interpolated onto a common 1 s grid</a:t>
+              <a:t>FHR‑value MAE / RMSE (bpm) — estimated vs. ground‑truth FHR, interpolated onto a common 1 s grid</a:t>
             </a:r>
           </a:p>
         </p:txBody>
@@ -6368,7 +6368,7 @@
           <a:noFill/>
         </p:spPr>
         <p:txBody>
-          <a:bodyPr wrap="none">
+          <a:bodyPr wrap="square">
             <a:spAutoFit/>
           </a:bodyPr>
           <a:lstStyle/>
@@ -6582,7 +6582,7 @@
           </a:bodyPr>
           <a:lstStyle/>
           <a:p>
-            <a:pPr>
+            <a:pPr marL="274320" indent="-274320">
               <a:spcAft>
                 <a:spcPts val="1200"/>
               </a:spcAft>
@@ -6625,7 +6625,7 @@
             </a:r>
           </a:p>
           <a:p>
-            <a:pPr>
+            <a:pPr marL="274320" indent="-274320">
               <a:spcAft>
                 <a:spcPts val="1200"/>
               </a:spcAft>
@@ -6659,7 +6659,7 @@
             </a:r>
           </a:p>
           <a:p>
-            <a:pPr>
+            <a:pPr marL="274320" indent="-274320">
               <a:spcAft>
                 <a:spcPts val="1200"/>
               </a:spcAft>
@@ -6680,7 +6680,7 @@
                 </a:solidFill>
                 <a:latin typeface="Calibri"/>
               </a:rPr>
-              <a:t>Box plots: SA's spread is tighter and more consistent — ICA is bimodal (several near-perfect records, several collapsed as low as ~0.23)</a:t>
+              <a:t>Box plots: SA's spread is tighter and more consistent — ICA is bimodal (several near‑perfect records, several collapsed as low as ~0.23)</a:t>
             </a:r>
           </a:p>
         </p:txBody>
@@ -6785,7 +6785,7 @@
                 </a:solidFill>
                 <a:latin typeface="Calibri"/>
               </a:rPr>
-              <a:t>Figure 8. success rate &amp; reliability</a:t>
+              <a:t>Figure 7. success rate &amp; reliability</a:t>
             </a:r>
           </a:p>
         </p:txBody>
@@ -6807,7 +6807,7 @@
           <a:noFill/>
         </p:spPr>
         <p:txBody>
-          <a:bodyPr wrap="none">
+          <a:bodyPr wrap="square">
             <a:spAutoFit/>
           </a:bodyPr>
           <a:lstStyle/>
@@ -6950,7 +6950,7 @@
                 </a:solidFill>
                 <a:latin typeface="Calibri"/>
               </a:rPr>
-              <a:t>Results II: ground-truth precision / recall / F1 (headline slide)</a:t>
+              <a:t>Results II: ground‑truth precision / recall / F1 (headline slide)</a:t>
             </a:r>
           </a:p>
         </p:txBody>
@@ -7021,7 +7021,7 @@
           </a:bodyPr>
           <a:lstStyle/>
           <a:p>
-            <a:pPr>
+            <a:pPr marL="274320" indent="-274320">
               <a:spcAft>
                 <a:spcPts val="1200"/>
               </a:spcAft>
@@ -7046,7 +7046,7 @@
             </a:r>
           </a:p>
           <a:p>
-            <a:pPr>
+            <a:pPr marL="274320" indent="-274320">
               <a:spcAft>
                 <a:spcPts val="1200"/>
               </a:spcAft>
@@ -7071,7 +7071,7 @@
             </a:r>
           </a:p>
           <a:p>
-            <a:pPr>
+            <a:pPr marL="274320" indent="-274320">
               <a:spcAft>
                 <a:spcPts val="1200"/>
               </a:spcAft>
@@ -7092,7 +7092,7 @@
                 </a:solidFill>
                 <a:latin typeface="Calibri"/>
               </a:rPr>
-              <a:t>Matched against real `.fqrs` ground-truth annotations, ±50 ms tolerance, all 25 records</a:t>
+              <a:t>Matched against real `.fqrs` ground‑truth annotations, ±50 ms tolerance, all 25 records</a:t>
             </a:r>
           </a:p>
         </p:txBody>
@@ -7197,7 +7197,7 @@
                 </a:solidFill>
                 <a:latin typeface="Calibri"/>
               </a:rPr>
-              <a:t>Figure 9. ground-truth precision / recall / F1</a:t>
+              <a:t>Figure 8. ground-truth precision / recall / F1</a:t>
             </a:r>
           </a:p>
         </p:txBody>
@@ -7219,7 +7219,7 @@
           <a:noFill/>
         </p:spPr>
         <p:txBody>
-          <a:bodyPr wrap="none">
+          <a:bodyPr wrap="square">
             <a:spAutoFit/>
           </a:bodyPr>
           <a:lstStyle/>
@@ -7362,7 +7362,7 @@
                 </a:solidFill>
                 <a:latin typeface="Calibri"/>
               </a:rPr>
-              <a:t>Results III: FHR-value accuracy (MAE/RMSE)</a:t>
+              <a:t>Results III: FHR‑value accuracy (MAE/RMSE)</a:t>
             </a:r>
           </a:p>
         </p:txBody>
@@ -7433,7 +7433,7 @@
           </a:bodyPr>
           <a:lstStyle/>
           <a:p>
-            <a:pPr>
+            <a:pPr marL="274320" indent="-274320">
               <a:spcAft>
                 <a:spcPts val="1200"/>
               </a:spcAft>
@@ -7458,7 +7458,7 @@
             </a:r>
           </a:p>
           <a:p>
-            <a:pPr>
+            <a:pPr marL="274320" indent="-274320">
               <a:spcAft>
                 <a:spcPts val="1200"/>
               </a:spcAft>
@@ -7483,7 +7483,7 @@
             </a:r>
           </a:p>
           <a:p>
-            <a:pPr>
+            <a:pPr marL="274320" indent="-274320">
               <a:spcAft>
                 <a:spcPts val="1200"/>
               </a:spcAft>
@@ -7504,7 +7504,7 @@
                 </a:solidFill>
                 <a:latin typeface="Calibri"/>
               </a:rPr>
-              <a:t>Estimated vs. ground-truth FHR, all 25 records, common 1-second grid</a:t>
+              <a:t>Estimated vs. ground‑truth FHR, all 25 records, common 1‑second grid</a:t>
             </a:r>
           </a:p>
         </p:txBody>
@@ -7609,7 +7609,7 @@
                 </a:solidFill>
                 <a:latin typeface="Calibri"/>
               </a:rPr>
-              <a:t>Figure 10. FHR-value accuracy</a:t>
+              <a:t>Figure 9. FHR-value accuracy</a:t>
             </a:r>
           </a:p>
         </p:txBody>
@@ -7631,7 +7631,7 @@
           <a:noFill/>
         </p:spPr>
         <p:txBody>
-          <a:bodyPr wrap="none">
+          <a:bodyPr wrap="square">
             <a:spAutoFit/>
           </a:bodyPr>
           <a:lstStyle/>
@@ -7845,7 +7845,7 @@
           </a:bodyPr>
           <a:lstStyle/>
           <a:p>
-            <a:pPr>
+            <a:pPr marL="274320" indent="-274320">
               <a:spcAft>
                 <a:spcPts val="1200"/>
               </a:spcAft>
@@ -7866,11 +7866,11 @@
                 </a:solidFill>
                 <a:latin typeface="Calibri"/>
               </a:rPr>
-              <a:t>F1 recomputed at 10 / 25 / 50 / 75 / 100 ms ground-truth matching tolerances</a:t>
-            </a:r>
-          </a:p>
-          <a:p>
-            <a:pPr>
+              <a:t>F1 recomputed at 10 / 25 / 50 / 75 / 100 ms ground‑truth matching tolerances</a:t>
+            </a:r>
+          </a:p>
+          <a:p>
+            <a:pPr marL="274320" indent="-274320">
               <a:spcAft>
                 <a:spcPts val="1200"/>
               </a:spcAft>
@@ -7913,7 +7913,7 @@
             </a:r>
           </a:p>
           <a:p>
-            <a:pPr>
+            <a:pPr marL="274320" indent="-274320">
               <a:spcAft>
                 <a:spcPts val="1200"/>
               </a:spcAft>
@@ -7934,7 +7934,7 @@
                 </a:solidFill>
                 <a:latin typeface="Calibri"/>
               </a:rPr>
-              <a:t>Confirms the ±50 ms headline result wasn't a cherry-picked threshold</a:t>
+              <a:t>Confirms the ±50 ms headline result wasn't a cherry‑picked threshold</a:t>
             </a:r>
           </a:p>
         </p:txBody>
@@ -8039,7 +8039,7 @@
                 </a:solidFill>
                 <a:latin typeface="Calibri"/>
               </a:rPr>
-              <a:t>Figure 11. robustness to matching tolerance</a:t>
+              <a:t>Figure 10. robustness to matching tolerance</a:t>
             </a:r>
           </a:p>
         </p:txBody>
@@ -8061,7 +8061,7 @@
           <a:noFill/>
         </p:spPr>
         <p:txBody>
-          <a:bodyPr wrap="none">
+          <a:bodyPr wrap="square">
             <a:spAutoFit/>
           </a:bodyPr>
           <a:lstStyle/>
@@ -8275,7 +8275,7 @@
           </a:bodyPr>
           <a:lstStyle/>
           <a:p>
-            <a:pPr>
+            <a:pPr marL="274320" indent="-274320">
               <a:spcAft>
                 <a:spcPts val="1200"/>
               </a:spcAft>
@@ -8327,7 +8327,7 @@
             </a:r>
           </a:p>
           <a:p>
-            <a:pPr>
+            <a:pPr marL="274320" indent="-274320">
               <a:spcAft>
                 <a:spcPts val="1200"/>
               </a:spcAft>
@@ -8352,7 +8352,7 @@
             </a:r>
           </a:p>
           <a:p>
-            <a:pPr>
+            <a:pPr marL="274320" indent="-274320">
               <a:spcAft>
                 <a:spcPts val="1200"/>
               </a:spcAft>
@@ -8458,8 +8458,8 @@
         </p:nvSpPr>
         <p:spPr>
           <a:xfrm>
-            <a:off x="5438149" y="1179576"/>
-            <a:ext cx="5886061" cy="4892040"/>
+            <a:off x="5018720" y="1873262"/>
+            <a:ext cx="4210318" cy="3504667"/>
           </a:xfrm>
           <a:prstGeom prst="rect">
             <a:avLst/>
@@ -8512,8 +8512,8 @@
         </p:blipFill>
         <p:spPr>
           <a:xfrm>
-            <a:off x="5493013" y="1234440"/>
-            <a:ext cx="5776333" cy="4782312"/>
+            <a:off x="5073584" y="1928126"/>
+            <a:ext cx="4100590" cy="3394939"/>
           </a:xfrm>
           <a:prstGeom prst="rect">
             <a:avLst/>
@@ -8528,8 +8528,8 @@
         </p:nvSpPr>
         <p:spPr>
           <a:xfrm>
-            <a:off x="5073584" y="6108192"/>
-            <a:ext cx="6615190" cy="274320"/>
+            <a:off x="5073584" y="5414505"/>
+            <a:ext cx="4100590" cy="274320"/>
           </a:xfrm>
           <a:prstGeom prst="rect">
             <a:avLst/>
@@ -8550,7 +8550,7 @@
                 </a:solidFill>
                 <a:latin typeface="Calibri"/>
               </a:rPr>
-              <a:t>Figure 12. signal quality drives reliability</a:t>
+              <a:t>Figure 11. signal quality drives reliability</a:t>
             </a:r>
           </a:p>
         </p:txBody>
@@ -8563,8 +8563,8 @@
         </p:nvSpPr>
         <p:spPr>
           <a:xfrm>
-            <a:off x="9393631" y="1225296"/>
-            <a:ext cx="2304288" cy="1814931"/>
+            <a:off x="9347911" y="2682605"/>
+            <a:ext cx="2395728" cy="1885981"/>
           </a:xfrm>
           <a:prstGeom prst="rect">
             <a:avLst/>
@@ -8617,8 +8617,8 @@
         </p:blipFill>
         <p:spPr>
           <a:xfrm>
-            <a:off x="9448495" y="1280160"/>
-            <a:ext cx="2194560" cy="1705203"/>
+            <a:off x="9402775" y="2737469"/>
+            <a:ext cx="2286000" cy="1776253"/>
           </a:xfrm>
           <a:prstGeom prst="rect">
             <a:avLst/>
@@ -8642,7 +8642,7 @@
           <a:noFill/>
         </p:spPr>
         <p:txBody>
-          <a:bodyPr wrap="none">
+          <a:bodyPr wrap="square">
             <a:spAutoFit/>
           </a:bodyPr>
           <a:lstStyle/>
@@ -8785,7 +8785,7 @@
                 </a:solidFill>
                 <a:latin typeface="Calibri"/>
               </a:rPr>
-              <a:t>Discussion: why non-blind wins, and where it struggles</a:t>
+              <a:t>Discussion: why non‑blind wins, and where it struggles</a:t>
             </a:r>
           </a:p>
         </p:txBody>
@@ -8842,8 +8842,8 @@
         </p:nvSpPr>
         <p:spPr>
           <a:xfrm>
-            <a:off x="502920" y="1508760"/>
-            <a:ext cx="11185855" cy="4828032"/>
+            <a:off x="502920" y="2223516"/>
+            <a:ext cx="11185855" cy="4113275"/>
           </a:xfrm>
           <a:prstGeom prst="rect">
             <a:avLst/>
@@ -8856,7 +8856,7 @@
           </a:bodyPr>
           <a:lstStyle/>
           <a:p>
-            <a:pPr>
+            <a:pPr marL="274320" indent="-274320">
               <a:spcAft>
                 <a:spcPts val="1200"/>
               </a:spcAft>
@@ -8917,7 +8917,7 @@
             </a:r>
           </a:p>
           <a:p>
-            <a:pPr>
+            <a:pPr marL="274320" indent="-274320">
               <a:spcAft>
                 <a:spcPts val="1200"/>
               </a:spcAft>
@@ -8942,7 +8942,7 @@
             </a:r>
           </a:p>
           <a:p>
-            <a:pPr>
+            <a:pPr marL="274320" indent="-274320">
               <a:spcAft>
                 <a:spcPts val="1200"/>
               </a:spcAft>
@@ -8963,11 +8963,11 @@
                 </a:solidFill>
                 <a:latin typeface="Calibri"/>
               </a:rPr>
-              <a:t>Limitations, honestly: 7/25 records needed short NaN-gap interpolation; a handful of records (a18, a09, a02, a11, a15) show markedly lower recall</a:t>
-            </a:r>
-          </a:p>
-          <a:p>
-            <a:pPr>
+              <a:t>Limitations, honestly: 7/25 records needed short NaN‑gap interpolation; a handful of records (a18, a09, a02, a11, a15) show markedly lower recall</a:t>
+            </a:r>
+          </a:p>
+          <a:p>
+            <a:pPr marL="274320" indent="-274320">
               <a:spcAft>
                 <a:spcPts val="1200"/>
               </a:spcAft>
@@ -9010,7 +9010,7 @@
           <a:noFill/>
         </p:spPr>
         <p:txBody>
-          <a:bodyPr wrap="none">
+          <a:bodyPr wrap="square">
             <a:spAutoFit/>
           </a:bodyPr>
           <a:lstStyle/>
@@ -9210,8 +9210,8 @@
         </p:nvSpPr>
         <p:spPr>
           <a:xfrm>
-            <a:off x="502920" y="1508760"/>
-            <a:ext cx="11185855" cy="4828032"/>
+            <a:off x="502920" y="2378456"/>
+            <a:ext cx="11185855" cy="3958336"/>
           </a:xfrm>
           <a:prstGeom prst="rect">
             <a:avLst/>
@@ -9224,7 +9224,7 @@
           </a:bodyPr>
           <a:lstStyle/>
           <a:p>
-            <a:pPr>
+            <a:pPr marL="274320" indent="-274320">
               <a:spcAft>
                 <a:spcPts val="1200"/>
               </a:spcAft>
@@ -9245,7 +9245,7 @@
                 </a:solidFill>
                 <a:latin typeface="Calibri"/>
               </a:rPr>
-              <a:t>Thesis supported on this dataset: non-blind sequential analysis is </a:t>
+              <a:t>Thesis supported on this dataset: non‑blind sequential analysis is </a:t>
             </a:r>
             <a:r>
               <a:rPr b="1" sz="2000">
@@ -9267,7 +9267,7 @@
             </a:r>
           </a:p>
           <a:p>
-            <a:pPr>
+            <a:pPr marL="274320" indent="-274320">
               <a:spcAft>
                 <a:spcPts val="1200"/>
               </a:spcAft>
@@ -9288,11 +9288,11 @@
                 </a:solidFill>
                 <a:latin typeface="Calibri"/>
               </a:rPr>
-              <a:t>Gap is largest precisely where it matters most: low-SNR/SIR recordings</a:t>
-            </a:r>
-          </a:p>
-          <a:p>
-            <a:pPr>
+              <a:t>Gap is largest precisely where it matters most: low‑SNR/SIR recordings</a:t>
+            </a:r>
+          </a:p>
+          <a:p>
+            <a:pPr marL="274320" indent="-274320">
               <a:spcAft>
                 <a:spcPts val="1200"/>
               </a:spcAft>
@@ -9313,11 +9313,11 @@
                 </a:solidFill>
                 <a:latin typeface="Calibri"/>
               </a:rPr>
-              <a:t>Practical relevance: viable direction for affordable, non-invasive, potentially home-based fetal monitoring</a:t>
-            </a:r>
-          </a:p>
-          <a:p>
-            <a:pPr>
+              <a:t>Practical relevance: viable direction for affordable, non‑invasive, potentially home‑based fetal monitoring</a:t>
+            </a:r>
+          </a:p>
+          <a:p>
+            <a:pPr marL="274320" indent="-274320">
               <a:spcAft>
                 <a:spcPts val="1200"/>
               </a:spcAft>
@@ -9338,7 +9338,7 @@
                 </a:solidFill>
                 <a:latin typeface="Calibri"/>
               </a:rPr>
-              <a:t>Future work: reduced electrode montages, dynamic MECG windows accounting for heart-rate-dependent QT variation, improved fetal-QRS detector for the low-recall records</a:t>
+              <a:t>Future work: reduced electrode montages, dynamic MECG windows accounting for heart‑rate‑dependent QT variation, improved fetal‑QRS detector for the low‑recall records</a:t>
             </a:r>
           </a:p>
         </p:txBody>
@@ -9360,7 +9360,7 @@
           <a:noFill/>
         </p:spPr>
         <p:txBody>
-          <a:bodyPr wrap="none">
+          <a:bodyPr wrap="square">
             <a:spAutoFit/>
           </a:bodyPr>
           <a:lstStyle/>
@@ -9560,8 +9560,8 @@
         </p:nvSpPr>
         <p:spPr>
           <a:xfrm>
-            <a:off x="502920" y="1508760"/>
-            <a:ext cx="11185855" cy="4828032"/>
+            <a:off x="502920" y="2843276"/>
+            <a:ext cx="11185855" cy="3493515"/>
           </a:xfrm>
           <a:prstGeom prst="rect">
             <a:avLst/>
@@ -9574,7 +9574,7 @@
           </a:bodyPr>
           <a:lstStyle/>
           <a:p>
-            <a:pPr>
+            <a:pPr marL="274320" indent="-274320">
               <a:spcAft>
                 <a:spcPts val="1200"/>
               </a:spcAft>
@@ -9595,11 +9595,11 @@
                 </a:solidFill>
                 <a:latin typeface="Calibri"/>
               </a:rPr>
-              <a:t>Fetal cardiac activity → key indicator of fetal well-being</a:t>
-            </a:r>
-          </a:p>
-          <a:p>
-            <a:pPr>
+              <a:t>Fetal cardiac activity → key indicator of fetal well‑being</a:t>
+            </a:r>
+          </a:p>
+          <a:p>
+            <a:pPr marL="274320" indent="-274320">
               <a:spcAft>
                 <a:spcPts val="1200"/>
               </a:spcAft>
@@ -9642,7 +9642,7 @@
             </a:r>
           </a:p>
           <a:p>
-            <a:pPr>
+            <a:pPr marL="274320" indent="-274320">
               <a:spcAft>
                 <a:spcPts val="1200"/>
               </a:spcAft>
@@ -9667,7 +9667,7 @@
             </a:r>
           </a:p>
           <a:p>
-            <a:pPr>
+            <a:pPr marL="274320" indent="-274320">
               <a:spcAft>
                 <a:spcPts val="1200"/>
               </a:spcAft>
@@ -9688,7 +9688,7 @@
                 </a:solidFill>
                 <a:latin typeface="Calibri"/>
               </a:rPr>
-              <a:t>Abdominal FECG = non-invasive, usable throughout pregnancy </a:t>
+              <a:t>Abdominal FECG = non‑invasive, usable throughout pregnancy </a:t>
             </a:r>
             <a:r>
               <a:rPr i="1" sz="2000">
@@ -9706,7 +9706,7 @@
                 </a:solidFill>
                 <a:latin typeface="Calibri"/>
               </a:rPr>
-              <a:t> labour (vs. invasive scalp electrode, labour-only)</a:t>
+              <a:t> labour (vs. invasive scalp electrode, labour‑only)</a:t>
             </a:r>
           </a:p>
         </p:txBody>
@@ -9728,7 +9728,7 @@
           <a:noFill/>
         </p:spPr>
         <p:txBody>
-          <a:bodyPr wrap="none">
+          <a:bodyPr wrap="square">
             <a:spAutoFit/>
           </a:bodyPr>
           <a:lstStyle/>
@@ -9928,8 +9928,8 @@
         </p:nvSpPr>
         <p:spPr>
           <a:xfrm>
-            <a:off x="502920" y="1508760"/>
-            <a:ext cx="11185855" cy="4828032"/>
+            <a:off x="502920" y="3439972"/>
+            <a:ext cx="11185855" cy="2896819"/>
           </a:xfrm>
           <a:prstGeom prst="rect">
             <a:avLst/>
@@ -9942,7 +9942,7 @@
           </a:bodyPr>
           <a:lstStyle/>
           <a:p>
-            <a:pPr>
+            <a:pPr marL="274320" indent="-274320">
               <a:spcAft>
                 <a:spcPts val="1200"/>
               </a:spcAft>
@@ -9967,7 +9967,7 @@
             </a:r>
           </a:p>
           <a:p>
-            <a:pPr>
+            <a:pPr marL="274320" indent="-274320">
               <a:spcAft>
                 <a:spcPts val="1200"/>
               </a:spcAft>
@@ -10010,7 +10010,7 @@
           <a:noFill/>
         </p:spPr>
         <p:txBody>
-          <a:bodyPr wrap="none">
+          <a:bodyPr wrap="square">
             <a:spAutoFit/>
           </a:bodyPr>
           <a:lstStyle/>
@@ -10210,8 +10210,8 @@
         </p:nvSpPr>
         <p:spPr>
           <a:xfrm>
-            <a:off x="502920" y="1234440"/>
-            <a:ext cx="4250624" cy="5102352"/>
+            <a:off x="502920" y="2998216"/>
+            <a:ext cx="11185855" cy="3338575"/>
           </a:xfrm>
           <a:prstGeom prst="rect">
             <a:avLst/>
@@ -10219,18 +10219,18 @@
           <a:noFill/>
         </p:spPr>
         <p:txBody>
-          <a:bodyPr wrap="square" anchor="ctr">
+          <a:bodyPr wrap="square" anchor="t">
             <a:spAutoFit/>
           </a:bodyPr>
           <a:lstStyle/>
           <a:p>
-            <a:pPr>
+            <a:pPr marL="274320" indent="-274320">
               <a:spcAft>
                 <a:spcPts val="1200"/>
               </a:spcAft>
             </a:pPr>
             <a:r>
-              <a:rPr sz="1700">
+              <a:rPr sz="2000">
                 <a:solidFill>
                   <a:srgbClr val="16A085"/>
                 </a:solidFill>
@@ -10239,7 +10239,7 @@
               <a:t>▪  </a:t>
             </a:r>
             <a:r>
-              <a:rPr sz="1700">
+              <a:rPr sz="2000">
                 <a:solidFill>
                   <a:srgbClr val="2C3E50"/>
                 </a:solidFill>
@@ -10249,13 +10249,13 @@
             </a:r>
           </a:p>
           <a:p>
-            <a:pPr>
+            <a:pPr marL="274320" indent="-274320">
               <a:spcAft>
                 <a:spcPts val="1200"/>
               </a:spcAft>
             </a:pPr>
             <a:r>
-              <a:rPr sz="1700">
+              <a:rPr sz="2000">
                 <a:solidFill>
                   <a:srgbClr val="16A085"/>
                 </a:solidFill>
@@ -10264,23 +10264,23 @@
               <a:t>▪  </a:t>
             </a:r>
             <a:r>
-              <a:rPr sz="1700">
+              <a:rPr sz="2000">
                 <a:solidFill>
                   <a:srgbClr val="2C3E50"/>
                 </a:solidFill>
                 <a:latin typeface="Calibri"/>
               </a:rPr>
-              <a:t>Buried under: baseline wander, power-line interference, EMG/motion artifacts</a:t>
-            </a:r>
-          </a:p>
-          <a:p>
-            <a:pPr>
+              <a:t>Buried under: baseline wander, power‑line interference, EMG/motion artifacts</a:t>
+            </a:r>
+          </a:p>
+          <a:p>
+            <a:pPr marL="274320" indent="-274320">
               <a:spcAft>
                 <a:spcPts val="1200"/>
               </a:spcAft>
             </a:pPr>
             <a:r>
-              <a:rPr sz="1700">
+              <a:rPr sz="2000">
                 <a:solidFill>
                   <a:srgbClr val="16A085"/>
                 </a:solidFill>
@@ -10289,7 +10289,7 @@
               <a:t>▪  </a:t>
             </a:r>
             <a:r>
-              <a:rPr sz="1700">
+              <a:rPr sz="2000">
                 <a:solidFill>
                   <a:srgbClr val="2C3E50"/>
                 </a:solidFill>
@@ -10298,7 +10298,7 @@
               <a:t>Above all: the </a:t>
             </a:r>
             <a:r>
-              <a:rPr b="1" sz="1700">
+              <a:rPr b="1" sz="2000">
                 <a:solidFill>
                   <a:srgbClr val="2C3E50"/>
                 </a:solidFill>
@@ -10307,7 +10307,7 @@
               <a:t>mother's ECG (MECG)</a:t>
             </a:r>
             <a:r>
-              <a:rPr sz="1700">
+              <a:rPr sz="2000">
                 <a:solidFill>
                   <a:srgbClr val="2C3E50"/>
                 </a:solidFill>
@@ -10317,13 +10317,13 @@
             </a:r>
           </a:p>
           <a:p>
-            <a:pPr>
+            <a:pPr marL="274320" indent="-274320">
               <a:spcAft>
                 <a:spcPts val="1200"/>
               </a:spcAft>
             </a:pPr>
             <a:r>
-              <a:rPr sz="1700">
+              <a:rPr sz="2000">
                 <a:solidFill>
                   <a:srgbClr val="16A085"/>
                 </a:solidFill>
@@ -10332,7 +10332,7 @@
               <a:t>▪  </a:t>
             </a:r>
             <a:r>
-              <a:rPr sz="1700">
+              <a:rPr sz="2000">
                 <a:solidFill>
                   <a:srgbClr val="2C3E50"/>
                 </a:solidFill>
@@ -10345,85 +10345,14 @@
       </p:sp>
       <p:sp>
         <p:nvSpPr>
-          <p:cNvPr id="6" name="Rectangle 5"/>
-          <p:cNvSpPr/>
-          <p:nvPr/>
-        </p:nvSpPr>
-        <p:spPr>
-          <a:xfrm>
-            <a:off x="7024722" y="1179576"/>
-            <a:ext cx="2712914" cy="4892040"/>
-          </a:xfrm>
-          <a:prstGeom prst="rect">
-            <a:avLst/>
-          </a:prstGeom>
-          <a:solidFill>
-            <a:srgbClr val="FFFFFF"/>
-          </a:solidFill>
-          <a:ln w="9525">
-            <a:solidFill>
-              <a:srgbClr val="DDE1E5"/>
-            </a:solidFill>
-          </a:ln>
-          <a:effectLst/>
-        </p:spPr>
-        <p:style>
-          <a:lnRef idx="1">
-            <a:schemeClr val="accent1"/>
-          </a:lnRef>
-          <a:fillRef idx="3">
-            <a:schemeClr val="accent1"/>
-          </a:fillRef>
-          <a:effectRef idx="2">
-            <a:schemeClr val="accent1"/>
-          </a:effectRef>
-          <a:fontRef idx="minor">
-            <a:schemeClr val="lt1"/>
-          </a:fontRef>
-        </p:style>
-        <p:txBody>
-          <a:bodyPr rtlCol="0" anchor="ctr"/>
-          <a:lstStyle/>
-          <a:p>
-            <a:pPr algn="ctr"/>
-          </a:p>
-        </p:txBody>
-      </p:sp>
-      <p:pic>
-        <p:nvPicPr>
-          <p:cNvPr id="7" name="Picture 6" descr="sequential_analysis_pipeline.png"/>
-          <p:cNvPicPr>
-            <a:picLocks noChangeAspect="1"/>
-          </p:cNvPicPr>
-          <p:nvPr/>
-        </p:nvPicPr>
-        <p:blipFill>
-          <a:blip r:embed="rId2"/>
-          <a:srcRect r="73000"/>
-          <a:stretch>
-            <a:fillRect/>
-          </a:stretch>
-        </p:blipFill>
-        <p:spPr>
-          <a:xfrm>
-            <a:off x="7079586" y="1234440"/>
-            <a:ext cx="2603186" cy="4782312"/>
-          </a:xfrm>
-          <a:prstGeom prst="rect">
-            <a:avLst/>
-          </a:prstGeom>
-        </p:spPr>
-      </p:pic>
-      <p:sp>
-        <p:nvSpPr>
-          <p:cNvPr id="8" name="TextBox 7"/>
+          <p:cNvPr id="6" name="TextBox 5"/>
           <p:cNvSpPr txBox="1"/>
           <p:nvPr/>
         </p:nvSpPr>
         <p:spPr>
           <a:xfrm>
-            <a:off x="5073584" y="6108192"/>
-            <a:ext cx="6615190" cy="274320"/>
+            <a:off x="502920" y="6446520"/>
+            <a:ext cx="10637215" cy="320040"/>
           </a:xfrm>
           <a:prstGeom prst="rect">
             <a:avLst/>
@@ -10431,53 +10360,18 @@
           <a:noFill/>
         </p:spPr>
         <p:txBody>
-          <a:bodyPr wrap="none">
+          <a:bodyPr wrap="square">
             <a:spAutoFit/>
           </a:bodyPr>
           <a:lstStyle/>
           <a:p>
-            <a:pPr algn="ctr"/>
-            <a:r>
-              <a:rPr sz="1100" i="1">
+            <a:r>
+              <a:rPr sz="900" i="1">
                 <a:solidFill>
                   <a:srgbClr val="5A6B78"/>
                 </a:solidFill>
                 <a:latin typeface="Calibri"/>
               </a:rPr>
-              <a:t>Figure 1. The core challenge</a:t>
-            </a:r>
-          </a:p>
-        </p:txBody>
-      </p:sp>
-      <p:sp>
-        <p:nvSpPr>
-          <p:cNvPr id="9" name="TextBox 8"/>
-          <p:cNvSpPr txBox="1"/>
-          <p:nvPr/>
-        </p:nvSpPr>
-        <p:spPr>
-          <a:xfrm>
-            <a:off x="502920" y="6446520"/>
-            <a:ext cx="10637215" cy="320040"/>
-          </a:xfrm>
-          <a:prstGeom prst="rect">
-            <a:avLst/>
-          </a:prstGeom>
-          <a:noFill/>
-        </p:spPr>
-        <p:txBody>
-          <a:bodyPr wrap="none">
-            <a:spAutoFit/>
-          </a:bodyPr>
-          <a:lstStyle/>
-          <a:p>
-            <a:r>
-              <a:rPr sz="900" i="1">
-                <a:solidFill>
-                  <a:srgbClr val="5A6B78"/>
-                </a:solidFill>
-                <a:latin typeface="Calibri"/>
-              </a:rPr>
               <a:t>Robust Fetal ECG Detection -- Sequential Analysis vs. ICA</a:t>
             </a:r>
           </a:p>
@@ -10485,7 +10379,7 @@
       </p:sp>
       <p:sp>
         <p:nvSpPr>
-          <p:cNvPr id="10" name="TextBox 9"/>
+          <p:cNvPr id="7" name="TextBox 6"/>
           <p:cNvSpPr txBox="1"/>
           <p:nvPr/>
         </p:nvSpPr>
@@ -10666,8 +10560,8 @@
         </p:nvSpPr>
         <p:spPr>
           <a:xfrm>
-            <a:off x="868680" y="1691640"/>
-            <a:ext cx="5120640" cy="548640"/>
+            <a:off x="502920" y="2071116"/>
+            <a:ext cx="4480560" cy="548640"/>
           </a:xfrm>
           <a:prstGeom prst="roundRect">
             <a:avLst>
@@ -10721,8 +10615,8 @@
         </p:nvSpPr>
         <p:spPr>
           <a:xfrm>
-            <a:off x="6202375" y="1691640"/>
-            <a:ext cx="5120640" cy="548640"/>
+            <a:off x="7208215" y="2071116"/>
+            <a:ext cx="4480560" cy="548640"/>
           </a:xfrm>
           <a:prstGeom prst="roundRect">
             <a:avLst>
@@ -10763,7 +10657,7 @@
                 </a:solidFill>
                 <a:latin typeface="Calibri"/>
               </a:rPr>
-              <a:t>Non-blind (Sequential Analysis)</a:t>
+              <a:t>Non‑blind (Sequential Analysis)</a:t>
             </a:r>
           </a:p>
         </p:txBody>
@@ -10776,8 +10670,8 @@
         </p:nvSpPr>
         <p:spPr>
           <a:xfrm>
-            <a:off x="1097280" y="2468880"/>
-            <a:ext cx="4663440" cy="1920240"/>
+            <a:off x="731520" y="2848356"/>
+            <a:ext cx="4023360" cy="1920240"/>
           </a:xfrm>
           <a:prstGeom prst="rect">
             <a:avLst/>
@@ -10790,7 +10684,7 @@
           </a:bodyPr>
           <a:lstStyle/>
           <a:p>
-            <a:pPr>
+            <a:pPr marL="201168" indent="-201168">
               <a:spcAft>
                 <a:spcPts val="1000"/>
               </a:spcAft>
@@ -10806,7 +10700,7 @@
             </a:r>
           </a:p>
           <a:p>
-            <a:pPr>
+            <a:pPr marL="201168" indent="-201168">
               <a:spcAft>
                 <a:spcPts val="1000"/>
               </a:spcAft>
@@ -10822,7 +10716,7 @@
             </a:r>
           </a:p>
           <a:p>
-            <a:pPr>
+            <a:pPr marL="201168" indent="-201168">
               <a:spcAft>
                 <a:spcPts val="1000"/>
               </a:spcAft>
@@ -10847,8 +10741,8 @@
         </p:nvSpPr>
         <p:spPr>
           <a:xfrm>
-            <a:off x="6430975" y="2468880"/>
-            <a:ext cx="4663440" cy="1920240"/>
+            <a:off x="7436815" y="2848356"/>
+            <a:ext cx="4023360" cy="1920240"/>
           </a:xfrm>
           <a:prstGeom prst="rect">
             <a:avLst/>
@@ -10861,7 +10755,7 @@
           </a:bodyPr>
           <a:lstStyle/>
           <a:p>
-            <a:pPr>
+            <a:pPr marL="201168" indent="-201168">
               <a:spcAft>
                 <a:spcPts val="1000"/>
               </a:spcAft>
@@ -10877,7 +10771,7 @@
             </a:r>
           </a:p>
           <a:p>
-            <a:pPr>
+            <a:pPr marL="201168" indent="-201168">
               <a:spcAft>
                 <a:spcPts val="1000"/>
               </a:spcAft>
@@ -10893,7 +10787,7 @@
             </a:r>
           </a:p>
           <a:p>
-            <a:pPr>
+            <a:pPr marL="201168" indent="-201168">
               <a:spcAft>
                 <a:spcPts val="1000"/>
               </a:spcAft>
@@ -10918,8 +10812,8 @@
         </p:nvSpPr>
         <p:spPr>
           <a:xfrm>
-            <a:off x="868680" y="1691640"/>
-            <a:ext cx="5120640" cy="2743200"/>
+            <a:off x="502920" y="2071116"/>
+            <a:ext cx="4480560" cy="2743200"/>
           </a:xfrm>
           <a:prstGeom prst="roundRect">
             <a:avLst>
@@ -10964,8 +10858,8 @@
         </p:nvSpPr>
         <p:spPr>
           <a:xfrm>
-            <a:off x="6202375" y="1691640"/>
-            <a:ext cx="5120640" cy="2743200"/>
+            <a:off x="7208215" y="2071116"/>
+            <a:ext cx="4480560" cy="2743200"/>
           </a:xfrm>
           <a:prstGeom prst="roundRect">
             <a:avLst>
@@ -11010,7 +10904,7 @@
         </p:nvSpPr>
         <p:spPr>
           <a:xfrm>
-            <a:off x="5730087" y="2788920"/>
+            <a:off x="5730087" y="3168396"/>
             <a:ext cx="731520" cy="548640"/>
           </a:xfrm>
           <a:prstGeom prst="rect">
@@ -11045,7 +10939,7 @@
         </p:nvSpPr>
         <p:spPr>
           <a:xfrm>
-            <a:off x="502920" y="4754879"/>
+            <a:off x="502920" y="5134356"/>
             <a:ext cx="11185855" cy="822960"/>
           </a:xfrm>
           <a:prstGeom prst="rect">
@@ -11089,7 +10983,7 @@
           <a:noFill/>
         </p:spPr>
         <p:txBody>
-          <a:bodyPr wrap="none">
+          <a:bodyPr wrap="square">
             <a:spAutoFit/>
           </a:bodyPr>
           <a:lstStyle/>
@@ -11203,6 +11097,41 @@
           </a:p>
         </p:txBody>
       </p:sp>
+      <p:cxnSp>
+        <p:nvCxnSpPr>
+          <p:cNvPr id="18" name="Connector 17"/>
+          <p:cNvCxnSpPr/>
+          <p:nvPr/>
+        </p:nvCxnSpPr>
+        <p:spPr>
+          <a:xfrm>
+            <a:off x="502920" y="3108960"/>
+            <a:ext cx="11505895" cy="0"/>
+          </a:xfrm>
+          <a:prstGeom prst="line">
+            <a:avLst/>
+          </a:prstGeom>
+          <a:ln w="19050">
+            <a:solidFill>
+              <a:srgbClr val="DDE1E5"/>
+            </a:solidFill>
+          </a:ln>
+        </p:spPr>
+        <p:style>
+          <a:lnRef idx="2">
+            <a:schemeClr val="accent1"/>
+          </a:lnRef>
+          <a:fillRef idx="0">
+            <a:schemeClr val="accent1"/>
+          </a:fillRef>
+          <a:effectRef idx="1">
+            <a:schemeClr val="accent1"/>
+          </a:effectRef>
+          <a:fontRef idx="minor">
+            <a:schemeClr val="tx1"/>
+          </a:fontRef>
+        </p:style>
+      </p:cxnSp>
       <p:sp>
         <p:nvSpPr>
           <p:cNvPr id="3" name="TextBox 2"/>
@@ -11289,7 +11218,7 @@
         </p:nvSpPr>
         <p:spPr>
           <a:xfrm>
-            <a:off x="502920" y="2606040"/>
+            <a:off x="502920" y="2880360"/>
             <a:ext cx="594360" cy="457200"/>
           </a:xfrm>
           <a:prstGeom prst="roundRect">
@@ -11346,7 +11275,7 @@
         </p:nvSpPr>
         <p:spPr>
           <a:xfrm>
-            <a:off x="1013429" y="2514600"/>
+            <a:off x="1013429" y="2788920"/>
             <a:ext cx="1691640" cy="640080"/>
           </a:xfrm>
           <a:prstGeom prst="roundRect">
@@ -11402,7 +11331,7 @@
         </p:nvSpPr>
         <p:spPr>
           <a:xfrm>
-            <a:off x="2621219" y="2606040"/>
+            <a:off x="2621219" y="2880360"/>
             <a:ext cx="594360" cy="457200"/>
           </a:xfrm>
           <a:prstGeom prst="roundRect">
@@ -11459,7 +11388,7 @@
         </p:nvSpPr>
         <p:spPr>
           <a:xfrm>
-            <a:off x="3131728" y="2514600"/>
+            <a:off x="3131728" y="2788920"/>
             <a:ext cx="1691640" cy="640080"/>
           </a:xfrm>
           <a:prstGeom prst="roundRect">
@@ -11515,7 +11444,7 @@
         </p:nvSpPr>
         <p:spPr>
           <a:xfrm>
-            <a:off x="4739518" y="2606040"/>
+            <a:off x="4739518" y="2880360"/>
             <a:ext cx="594360" cy="457200"/>
           </a:xfrm>
           <a:prstGeom prst="roundRect">
@@ -11572,7 +11501,7 @@
         </p:nvSpPr>
         <p:spPr>
           <a:xfrm>
-            <a:off x="5250027" y="2514600"/>
+            <a:off x="5250027" y="2788920"/>
             <a:ext cx="1691640" cy="640080"/>
           </a:xfrm>
           <a:prstGeom prst="roundRect">
@@ -11614,7 +11543,7 @@
                 </a:solidFill>
                 <a:latin typeface="Calibri"/>
               </a:rPr>
-              <a:t>Sampling-Rate
+              <a:t>Sampling‑Rate
 Increaser</a:t>
             </a:r>
           </a:p>
@@ -11628,7 +11557,7 @@
         </p:nvSpPr>
         <p:spPr>
           <a:xfrm>
-            <a:off x="6857817" y="2606040"/>
+            <a:off x="6857817" y="2880360"/>
             <a:ext cx="594360" cy="457200"/>
           </a:xfrm>
           <a:prstGeom prst="roundRect">
@@ -11685,7 +11614,7 @@
         </p:nvSpPr>
         <p:spPr>
           <a:xfrm>
-            <a:off x="7094006" y="2130552"/>
+            <a:off x="7094006" y="2404872"/>
             <a:ext cx="2240280" cy="320040"/>
           </a:xfrm>
           <a:prstGeom prst="rect">
@@ -11720,7 +11649,7 @@
         </p:nvSpPr>
         <p:spPr>
           <a:xfrm>
-            <a:off x="7368326" y="2514600"/>
+            <a:off x="7368326" y="2788920"/>
             <a:ext cx="1691640" cy="640080"/>
           </a:xfrm>
           <a:prstGeom prst="roundRect">
@@ -11776,7 +11705,7 @@
         </p:nvSpPr>
         <p:spPr>
           <a:xfrm>
-            <a:off x="8976116" y="2606040"/>
+            <a:off x="8976116" y="2880360"/>
             <a:ext cx="594360" cy="457200"/>
           </a:xfrm>
           <a:prstGeom prst="roundRect">
@@ -11833,7 +11762,7 @@
         </p:nvSpPr>
         <p:spPr>
           <a:xfrm>
-            <a:off x="9212305" y="2130552"/>
+            <a:off x="9212305" y="2404872"/>
             <a:ext cx="2240280" cy="320040"/>
           </a:xfrm>
           <a:prstGeom prst="rect">
@@ -11868,7 +11797,7 @@
         </p:nvSpPr>
         <p:spPr>
           <a:xfrm>
-            <a:off x="9486625" y="2514600"/>
+            <a:off x="9486625" y="2788920"/>
             <a:ext cx="1691640" cy="640080"/>
           </a:xfrm>
           <a:prstGeom prst="roundRect">
@@ -11924,7 +11853,7 @@
         </p:nvSpPr>
         <p:spPr>
           <a:xfrm>
-            <a:off x="10934395" y="2606040"/>
+            <a:off x="10934395" y="2880360"/>
             <a:ext cx="914400" cy="457200"/>
           </a:xfrm>
           <a:prstGeom prst="roundRect">
@@ -11974,42 +11903,6 @@
           </a:p>
         </p:txBody>
       </p:sp>
-      <p:cxnSp>
-        <p:nvCxnSpPr>
-          <p:cNvPr id="18" name="Connector 17"/>
-          <p:cNvCxnSpPr/>
-          <p:nvPr/>
-        </p:nvCxnSpPr>
-        <p:spPr>
-          <a:xfrm>
-            <a:off x="502920" y="2834640"/>
-            <a:ext cx="11505895" cy="0"/>
-          </a:xfrm>
-          <a:prstGeom prst="line">
-            <a:avLst/>
-          </a:prstGeom>
-          <a:ln w="19050">
-            <a:solidFill>
-              <a:srgbClr val="DDE1E5"/>
-            </a:solidFill>
-            <a:tailEnd type="triangle" w="med" len="med"/>
-          </a:ln>
-        </p:spPr>
-        <p:style>
-          <a:lnRef idx="2">
-            <a:schemeClr val="accent1"/>
-          </a:lnRef>
-          <a:fillRef idx="0">
-            <a:schemeClr val="accent1"/>
-          </a:fillRef>
-          <a:effectRef idx="1">
-            <a:schemeClr val="accent1"/>
-          </a:effectRef>
-          <a:fontRef idx="minor">
-            <a:schemeClr val="tx1"/>
-          </a:fontRef>
-        </p:style>
-      </p:cxnSp>
       <p:sp>
         <p:nvSpPr>
           <p:cNvPr id="19" name="TextBox 18"/>
@@ -12018,7 +11911,7 @@
         </p:nvSpPr>
         <p:spPr>
           <a:xfrm>
-            <a:off x="502920" y="3703320"/>
+            <a:off x="502920" y="3977639"/>
             <a:ext cx="11185855" cy="548640"/>
           </a:xfrm>
           <a:prstGeom prst="rect">
@@ -12080,7 +11973,7 @@
           <a:noFill/>
         </p:spPr>
         <p:txBody>
-          <a:bodyPr wrap="none">
+          <a:bodyPr wrap="square">
             <a:spAutoFit/>
           </a:bodyPr>
           <a:lstStyle/>
@@ -12223,7 +12116,7 @@
                 </a:solidFill>
                 <a:latin typeface="Calibri"/>
               </a:rPr>
-              <a:t>Stage 1–2 in practice: baseline wander + power-line interference</a:t>
+              <a:t>Stage 1–2 in practice: baseline wander + power‑line interference</a:t>
             </a:r>
           </a:p>
         </p:txBody>
@@ -12294,7 +12187,7 @@
           </a:bodyPr>
           <a:lstStyle/>
           <a:p>
-            <a:pPr>
+            <a:pPr marL="274320" indent="-274320">
               <a:spcAft>
                 <a:spcPts val="1200"/>
               </a:spcAft>
@@ -12315,7 +12208,7 @@
                 </a:solidFill>
                 <a:latin typeface="Calibri"/>
               </a:rPr>
-              <a:t>Baseline wander: linear-phase FIR high-pass, 3 Hz cutoff, Hamming window — </a:t>
+              <a:t>Baseline wander: linear‑phase FIR high‑pass, 3 Hz cutoff, Hamming window — </a:t>
             </a:r>
             <a:r>
               <a:rPr b="1" sz="1700">
@@ -12328,7 +12221,7 @@
             </a:r>
           </a:p>
           <a:p>
-            <a:pPr>
+            <a:pPr marL="274320" indent="-274320">
               <a:spcAft>
                 <a:spcPts val="1200"/>
               </a:spcAft>
@@ -12349,11 +12242,11 @@
                 </a:solidFill>
                 <a:latin typeface="Calibri"/>
               </a:rPr>
-              <a:t>Power-line interference: adaptive PLL-style canceller with a QRS-blocking mask (protects heartbeats while tracking the 50 Hz line) — same adaptive-cancellation spirit as the paper, different mechanism</a:t>
-            </a:r>
-          </a:p>
-          <a:p>
-            <a:pPr>
+              <a:t>Power‑line interference: adaptive PLL‑style canceller with a QRS‑blocking mask (protects heartbeats while tracking the 50 Hz line) — same adaptive‑cancellation spirit as the paper, different mechanism</a:t>
+            </a:r>
+          </a:p>
+          <a:p>
+            <a:pPr marL="274320" indent="-274320">
               <a:spcAft>
                 <a:spcPts val="1200"/>
               </a:spcAft>
@@ -12387,8 +12280,8 @@
         </p:nvSpPr>
         <p:spPr>
           <a:xfrm>
-            <a:off x="5018720" y="1669294"/>
-            <a:ext cx="6724918" cy="3912603"/>
+            <a:off x="5018720" y="2392078"/>
+            <a:ext cx="4210318" cy="2467034"/>
           </a:xfrm>
           <a:prstGeom prst="rect">
             <a:avLst/>
@@ -12441,8 +12334,8 @@
         </p:blipFill>
         <p:spPr>
           <a:xfrm>
-            <a:off x="5073584" y="1724158"/>
-            <a:ext cx="6615190" cy="3802875"/>
+            <a:off x="5073584" y="2446942"/>
+            <a:ext cx="4100590" cy="2357306"/>
           </a:xfrm>
           <a:prstGeom prst="rect">
             <a:avLst/>
@@ -12457,8 +12350,8 @@
         </p:nvSpPr>
         <p:spPr>
           <a:xfrm>
-            <a:off x="5073584" y="5618473"/>
-            <a:ext cx="6615190" cy="274320"/>
+            <a:off x="5073584" y="4895689"/>
+            <a:ext cx="4100590" cy="274320"/>
           </a:xfrm>
           <a:prstGeom prst="rect">
             <a:avLst/>
@@ -12479,7 +12372,7 @@
                 </a:solidFill>
                 <a:latin typeface="Calibri"/>
               </a:rPr>
-              <a:t>Figure 2. baseline wander + power-line interference</a:t>
+              <a:t>Figure 1. baseline wander + power-line interference</a:t>
             </a:r>
           </a:p>
         </p:txBody>
@@ -12492,8 +12385,8 @@
         </p:nvSpPr>
         <p:spPr>
           <a:xfrm>
-            <a:off x="9393631" y="1225296"/>
-            <a:ext cx="2304288" cy="893763"/>
+            <a:off x="9347911" y="3162380"/>
+            <a:ext cx="2395728" cy="926431"/>
           </a:xfrm>
           <a:prstGeom prst="rect">
             <a:avLst/>
@@ -12546,8 +12439,8 @@
         </p:blipFill>
         <p:spPr>
           <a:xfrm>
-            <a:off x="9448495" y="1280160"/>
-            <a:ext cx="2194560" cy="784035"/>
+            <a:off x="9402775" y="3217244"/>
+            <a:ext cx="2286000" cy="816703"/>
           </a:xfrm>
           <a:prstGeom prst="rect">
             <a:avLst/>
@@ -12571,7 +12464,7 @@
           <a:noFill/>
         </p:spPr>
         <p:txBody>
-          <a:bodyPr wrap="none">
+          <a:bodyPr wrap="square">
             <a:spAutoFit/>
           </a:bodyPr>
           <a:lstStyle/>
@@ -12785,7 +12678,7 @@
           </a:bodyPr>
           <a:lstStyle/>
           <a:p>
-            <a:pPr>
+            <a:pPr marL="274320" indent="-274320">
               <a:spcAft>
                 <a:spcPts val="1200"/>
               </a:spcAft>
@@ -12806,7 +12699,7 @@
                 </a:solidFill>
                 <a:latin typeface="Calibri"/>
               </a:rPr>
-              <a:t>Maternal QRS detection: PCA channel-combination (maximizes SNR) + cross-correlation matched filter — </a:t>
+              <a:t>Maternal QRS detection: PCA channel‑combination (maximises SNR) + cross‑correlation matched filter — </a:t>
             </a:r>
             <a:r>
               <a:rPr b="1" sz="1700">
@@ -12819,7 +12712,7 @@
             </a:r>
           </a:p>
           <a:p>
-            <a:pPr>
+            <a:pPr marL="274320" indent="-274320">
               <a:spcAft>
                 <a:spcPts val="1200"/>
               </a:spcAft>
@@ -12840,7 +12733,7 @@
                 </a:solidFill>
                 <a:latin typeface="Calibri"/>
               </a:rPr>
-              <a:t>MECG cancellation: average P-wave/QRS/T-wave templates, each </a:t>
+              <a:t>MECG cancellation: average P‑wave/QRS/T‑wave templates, each </a:t>
             </a:r>
             <a:r>
               <a:rPr b="1" sz="1700">
@@ -12862,7 +12755,7 @@
             </a:r>
           </a:p>
           <a:p>
-            <a:pPr>
+            <a:pPr marL="274320" indent="-274320">
               <a:spcAft>
                 <a:spcPts val="1200"/>
               </a:spcAft>
@@ -12892,7 +12785,7 @@
                 </a:solidFill>
                 <a:latin typeface="Calibri"/>
               </a:rPr>
-              <a:t>Ridge (Tikhonov) regularization</a:t>
+              <a:t>Ridge (Tikhonov) regularisation</a:t>
             </a:r>
             <a:r>
               <a:rPr sz="1700">
@@ -12901,7 +12794,7 @@
                 </a:solidFill>
                 <a:latin typeface="Calibri"/>
               </a:rPr>
-              <a:t> to that least-squares fit for numerical stability — one deviation from the original paper</a:t>
+              <a:t> to that least‑squares fit for numerical stability — one deviation from the original paper</a:t>
             </a:r>
           </a:p>
         </p:txBody>
@@ -13006,7 +12899,7 @@
                 </a:solidFill>
                 <a:latin typeface="Calibri"/>
               </a:rPr>
-              <a:t>Figure 3. maternal QRS detection &amp; MECG cancellation</a:t>
+              <a:t>Figure 2. maternal QRS detection &amp; MECG cancellation</a:t>
             </a:r>
           </a:p>
         </p:txBody>
@@ -13028,7 +12921,7 @@
           <a:noFill/>
         </p:spPr>
         <p:txBody>
-          <a:bodyPr wrap="none">
+          <a:bodyPr wrap="square">
             <a:spAutoFit/>
           </a:bodyPr>
           <a:lstStyle/>
@@ -13242,7 +13135,7 @@
           </a:bodyPr>
           <a:lstStyle/>
           <a:p>
-            <a:pPr>
+            <a:pPr marL="274320" indent="-274320">
               <a:spcAft>
                 <a:spcPts val="1200"/>
               </a:spcAft>
@@ -13263,11 +13156,11 @@
                 </a:solidFill>
                 <a:latin typeface="Calibri"/>
               </a:rPr>
-              <a:t>PCA enhancement of the MECG-free signal</a:t>
-            </a:r>
-          </a:p>
-          <a:p>
-            <a:pPr>
+              <a:t>PCA enhancement of the MECG‑free signal</a:t>
+            </a:r>
+          </a:p>
+          <a:p>
+            <a:pPr marL="274320" indent="-274320">
               <a:spcAft>
                 <a:spcPts val="1200"/>
               </a:spcAft>
@@ -13288,7 +13181,7 @@
                 </a:solidFill>
                 <a:latin typeface="Calibri"/>
               </a:rPr>
-              <a:t>Candidate peaks: squared-signal </a:t>
+              <a:t>Candidate peaks: squared‑signal </a:t>
             </a:r>
             <a:r>
               <a:rPr b="1" sz="1700">
@@ -13301,7 +13194,7 @@
             </a:r>
           </a:p>
           <a:p>
-            <a:pPr>
+            <a:pPr marL="274320" indent="-274320">
               <a:spcAft>
                 <a:spcPts val="1200"/>
               </a:spcAft>
@@ -13322,11 +13215,11 @@
                 </a:solidFill>
                 <a:latin typeface="Calibri"/>
               </a:rPr>
-              <a:t>Refinement: cross-correlation matched filter</a:t>
-            </a:r>
-          </a:p>
-          <a:p>
-            <a:pPr>
+              <a:t>Refinement: cross‑correlation matched filter</a:t>
+            </a:r>
+          </a:p>
+          <a:p>
+            <a:pPr marL="274320" indent="-274320">
               <a:spcAft>
                 <a:spcPts val="1200"/>
               </a:spcAft>
@@ -13360,8 +13253,8 @@
         </p:nvSpPr>
         <p:spPr>
           <a:xfrm>
-            <a:off x="6067552" y="1179576"/>
-            <a:ext cx="4627254" cy="4892040"/>
+            <a:off x="5923376" y="1179576"/>
+            <a:ext cx="4915607" cy="4892040"/>
           </a:xfrm>
           <a:prstGeom prst="rect">
             <a:avLst/>
@@ -13408,15 +13301,15 @@
         </p:nvPicPr>
         <p:blipFill>
           <a:blip r:embed="rId2"/>
-          <a:srcRect l="50000"/>
+          <a:srcRect l="50000" t="6000"/>
           <a:stretch>
             <a:fillRect/>
           </a:stretch>
         </p:blipFill>
         <p:spPr>
           <a:xfrm>
-            <a:off x="6122416" y="1234440"/>
-            <a:ext cx="4517526" cy="4782312"/>
+            <a:off x="5978240" y="1234440"/>
+            <a:ext cx="4805879" cy="4782312"/>
           </a:xfrm>
           <a:prstGeom prst="rect">
             <a:avLst/>
@@ -13453,7 +13346,7 @@
                 </a:solidFill>
                 <a:latin typeface="Calibri"/>
               </a:rPr>
-              <a:t>Figure 4. fetal QRS detection &amp; FECG extraction</a:t>
+              <a:t>Figure 3. fetal QRS detection &amp; FECG extraction</a:t>
             </a:r>
           </a:p>
         </p:txBody>
@@ -13475,7 +13368,7 @@
           <a:noFill/>
         </p:spPr>
         <p:txBody>
-          <a:bodyPr wrap="none">
+          <a:bodyPr wrap="square">
             <a:spAutoFit/>
           </a:bodyPr>
           <a:lstStyle/>
@@ -13689,7 +13582,7 @@
           </a:bodyPr>
           <a:lstStyle/>
           <a:p>
-            <a:pPr>
+            <a:pPr marL="274320" indent="-274320">
               <a:spcAft>
                 <a:spcPts val="1200"/>
               </a:spcAft>
@@ -13714,7 +13607,7 @@
             </a:r>
           </a:p>
           <a:p>
-            <a:pPr>
+            <a:pPr marL="274320" indent="-274320">
               <a:spcAft>
                 <a:spcPts val="1200"/>
               </a:spcAft>
@@ -13840,7 +13733,7 @@
                 </a:solidFill>
                 <a:latin typeface="Calibri"/>
               </a:rPr>
-              <a:t>Figure 5. Full pipeline at a glance</a:t>
+              <a:t>Figure 4. Full pipeline at a glance</a:t>
             </a:r>
           </a:p>
         </p:txBody>
@@ -13862,7 +13755,7 @@
           <a:noFill/>
         </p:spPr>
         <p:txBody>
-          <a:bodyPr wrap="none">
+          <a:bodyPr wrap="square">
             <a:spAutoFit/>
           </a:bodyPr>
           <a:lstStyle/>

</xml_diff>